<commit_message>
Link the live app and keep the queue table readable at narrow widths
- README, solution document and deck now point to the deployed app
- Queue table uses fixed column widths so Band and Status are not clipped
- Reasons chart leaves room for the value label on its longest bar

Co-Authored-By: Claude Opus 5.5 <noreply@anthropic.com>
</commit_message>
<xml_diff>
--- a/docs/FraudLens_Pitch.pptx
+++ b/docs/FraudLens_Pitch.pptx
@@ -109,7 +109,7 @@
   <p:extLst>
     <p:ext uri="{521415D9-36F7-43E2-AB2F-B90AF26B5E84}">
       <p14:sectionLst xmlns:p14="http://schemas.microsoft.com/office/powerpoint/2010/main">
-        <p14:section name="Pitch" id="{17f2db52-5599-57bf-5152-f9b9090ad576}">
+        <p14:section name="Pitch" id="{59ad748d-35af-0d08-e20a-be146a561649}">
           <p14:sldIdLst>
             <p14:sldId id="256"/>
             <p14:sldId id="257"/>
@@ -1127,7 +1127,7 @@
                   <a:srgbClr val="5F6B7A"/>
                 </a:solidFill>
               </a:rPr>
-              <a:t>FraudLens  ·  Maverick Mini Hackathon  ·  Project 5</a:t>
+              <a:t>FraudLens  ·  Maverick Mini Hackathon, Project 5  ·  Live app: fraudlens-triage.streamlit.app</a:t>
             </a:r>
             <a:endParaRPr lang="en-US" sz="1000" dirty="0"/>
           </a:p>
@@ -1279,7 +1279,7 @@
                   <a:srgbClr val="9FB0C6"/>
                 </a:solidFill>
               </a:rPr>
-              <a:t>FraudLens  ·  Maverick Mini Hackathon  ·  Project 5</a:t>
+              <a:t>FraudLens  ·  Maverick Mini Hackathon, Project 5  ·  Live app: fraudlens-triage.streamlit.app</a:t>
             </a:r>
             <a:endParaRPr lang="en-US" sz="1000" dirty="0"/>
           </a:p>

</xml_diff>